<commit_message>
Recalcular coordenadas de maquetacion en PowerPoint (.pptx) para eliminar desalineaciones y desbordamientos
</commit_message>
<xml_diff>
--- a/AXIOS_Initiative_Presentacion_Ejecutiva.pptx
+++ b/AXIOS_Initiative_Presentacion_Ejecutiva.pptx
@@ -1069,7 +1069,7 @@
         </p:blipFill>
         <p:spPr>
           <a:xfrm>
-            <a:off x="548640" y="457200"/>
+            <a:off x="457200" y="365760"/>
             <a:ext cx="2560320" cy="594360"/>
           </a:xfrm>
           <a:prstGeom prst="rect">
@@ -1085,8 +1085,8 @@
         </p:nvSpPr>
         <p:spPr>
           <a:xfrm>
-            <a:off x="548640" y="1280160"/>
-            <a:ext cx="5669280" cy="320040"/>
+            <a:off x="457200" y="1143000"/>
+            <a:ext cx="5120640" cy="320040"/>
           </a:xfrm>
           <a:prstGeom prst="rect">
             <a:avLst/>
@@ -1104,7 +1104,7 @@
               <a:buNone/>
             </a:pPr>
             <a:r>
-              <a:rPr lang="en-US" sz="1000" b="1" dirty="0">
+              <a:rPr lang="en-US" sz="950" b="1" dirty="0">
                 <a:solidFill>
                   <a:srgbClr val="FF8A50"/>
                 </a:solidFill>
@@ -1114,7 +1114,7 @@
               </a:rPr>
               <a:t>ORGANIZACIÓN CRISTIANA 501(c)(3) • ESTADO DE FLORIDA</a:t>
             </a:r>
-            <a:endParaRPr lang="en-US" sz="1000" dirty="0"/>
+            <a:endParaRPr lang="en-US" sz="950" dirty="0"/>
           </a:p>
         </p:txBody>
       </p:sp>
@@ -1126,8 +1126,8 @@
         </p:nvSpPr>
         <p:spPr>
           <a:xfrm>
-            <a:off x="548640" y="1737360"/>
-            <a:ext cx="5669280" cy="1463040"/>
+            <a:off x="457200" y="1600200"/>
+            <a:ext cx="5303520" cy="1463040"/>
           </a:xfrm>
           <a:prstGeom prst="rect">
             <a:avLst/>
@@ -1141,12 +1141,12 @@
           <a:p>
             <a:pPr indent="0" marL="0">
               <a:lnSpc>
-                <a:spcPts val="3400"/>
+                <a:spcPts val="3200"/>
               </a:lnSpc>
               <a:buNone/>
             </a:pPr>
             <a:r>
-              <a:rPr lang="en-US" sz="2800" b="1" dirty="0">
+              <a:rPr lang="en-US" sz="2600" b="1" dirty="0">
                 <a:solidFill>
                   <a:srgbClr val="FFFFFF"/>
                 </a:solidFill>
@@ -1156,17 +1156,17 @@
               </a:rPr>
               <a:t>Restaurando la dignidad,</a:t>
             </a:r>
-            <a:endParaRPr lang="en-US" sz="2800" dirty="0"/>
+            <a:endParaRPr lang="en-US" sz="2600" dirty="0"/>
           </a:p>
           <a:p>
             <a:pPr indent="0" marL="0">
               <a:lnSpc>
-                <a:spcPts val="3400"/>
+                <a:spcPts val="3200"/>
               </a:lnSpc>
               <a:buNone/>
             </a:pPr>
             <a:r>
-              <a:rPr lang="en-US" sz="2800" b="1" dirty="0">
+              <a:rPr lang="en-US" sz="2600" b="1" dirty="0">
                 <a:solidFill>
                   <a:srgbClr val="FFFFFF"/>
                 </a:solidFill>
@@ -1176,17 +1176,17 @@
               </a:rPr>
               <a:t>Honrando el llamado,</a:t>
             </a:r>
-            <a:endParaRPr lang="en-US" sz="2800" dirty="0"/>
+            <a:endParaRPr lang="en-US" sz="2600" dirty="0"/>
           </a:p>
           <a:p>
             <a:pPr indent="0" marL="0">
               <a:lnSpc>
-                <a:spcPts val="3400"/>
+                <a:spcPts val="3200"/>
               </a:lnSpc>
               <a:buNone/>
             </a:pPr>
             <a:r>
-              <a:rPr lang="en-US" sz="2800" b="1" dirty="0">
+              <a:rPr lang="en-US" sz="2600" b="1" dirty="0">
                 <a:solidFill>
                   <a:srgbClr val="FFFFFF"/>
                 </a:solidFill>
@@ -1196,7 +1196,7 @@
               </a:rPr>
               <a:t>Inspirando esperanza</a:t>
             </a:r>
-            <a:endParaRPr lang="en-US" sz="2800" dirty="0"/>
+            <a:endParaRPr lang="en-US" sz="2600" dirty="0"/>
           </a:p>
         </p:txBody>
       </p:sp>
@@ -1208,8 +1208,8 @@
         </p:nvSpPr>
         <p:spPr>
           <a:xfrm>
-            <a:off x="548640" y="3291840"/>
-            <a:ext cx="5669280" cy="914400"/>
+            <a:off x="457200" y="3154680"/>
+            <a:ext cx="5303520" cy="1005840"/>
           </a:xfrm>
           <a:prstGeom prst="rect">
             <a:avLst/>
@@ -1223,12 +1223,12 @@
           <a:p>
             <a:pPr indent="0" marL="0">
               <a:lnSpc>
-                <a:spcPts val="1800"/>
+                <a:spcPts val="1700"/>
               </a:lnSpc>
               <a:buNone/>
             </a:pPr>
             <a:r>
-              <a:rPr lang="en-US" sz="1300" dirty="0">
+              <a:rPr lang="en-US" sz="1200" dirty="0">
                 <a:solidFill>
                   <a:srgbClr val="E2E8F0"/>
                 </a:solidFill>
@@ -1238,7 +1238,7 @@
               </a:rPr>
               <a:t>Existimos para honrar, fortalecer y acompañar a pastores y sus familias, brindándoles atención integral, restauración, capacitación y apoyo financiero.</a:t>
             </a:r>
-            <a:endParaRPr lang="en-US" sz="1300" dirty="0"/>
+            <a:endParaRPr lang="en-US" sz="1200" dirty="0"/>
           </a:p>
         </p:txBody>
       </p:sp>
@@ -1258,10 +1258,10 @@
         </p:blipFill>
         <p:spPr>
           <a:xfrm>
-            <a:off x="6492240" y="548640"/>
-            <a:ext cx="5120640" cy="3657600"/>
-          </a:xfrm>
-          <a:prstGeom prst="ellipse">
+            <a:off x="6035040" y="365760"/>
+            <a:ext cx="5669280" cy="3886200"/>
+          </a:xfrm>
+          <a:prstGeom prst="rect">
             <a:avLst/>
           </a:prstGeom>
         </p:spPr>
@@ -1274,12 +1274,12 @@
         </p:nvSpPr>
         <p:spPr>
           <a:xfrm>
-            <a:off x="548640" y="4572000"/>
-            <a:ext cx="2606040" cy="1645920"/>
+            <a:off x="457200" y="4480560"/>
+            <a:ext cx="2633472" cy="1920240"/>
           </a:xfrm>
           <a:prstGeom prst="roundRect">
             <a:avLst>
-              <a:gd name="adj" fmla="val 5556"/>
+              <a:gd name="adj" fmla="val 4762"/>
             </a:avLst>
           </a:prstGeom>
           <a:solidFill>
@@ -1301,8 +1301,8 @@
         </p:nvSpPr>
         <p:spPr>
           <a:xfrm>
-            <a:off x="685800" y="4800600"/>
-            <a:ext cx="2331720" cy="320040"/>
+            <a:off x="566928" y="4663440"/>
+            <a:ext cx="2414016" cy="320040"/>
           </a:xfrm>
           <a:prstGeom prst="rect">
             <a:avLst/>
@@ -1314,11 +1314,11 @@
           <a:bodyPr wrap="square" rtlCol="0" anchor="ctr"/>
           <a:lstStyle/>
           <a:p>
-            <a:pPr indent="0" marL="0">
+            <a:pPr algn="ctr" indent="0" marL="0">
               <a:buNone/>
             </a:pPr>
             <a:r>
-              <a:rPr lang="en-US" sz="1400" b="1" dirty="0">
+              <a:rPr lang="en-US" sz="1300" b="1" dirty="0">
                 <a:solidFill>
                   <a:srgbClr val="FF8A50"/>
                 </a:solidFill>
@@ -1328,7 +1328,7 @@
               </a:rPr>
               <a:t>CUIDAR</a:t>
             </a:r>
-            <a:endParaRPr lang="en-US" sz="1400" dirty="0"/>
+            <a:endParaRPr lang="en-US" sz="1300" dirty="0"/>
           </a:p>
         </p:txBody>
       </p:sp>
@@ -1340,8 +1340,8 @@
         </p:nvSpPr>
         <p:spPr>
           <a:xfrm>
-            <a:off x="685800" y="5166360"/>
-            <a:ext cx="2331720" cy="822960"/>
+            <a:off x="566928" y="5029200"/>
+            <a:ext cx="2414016" cy="1188720"/>
           </a:xfrm>
           <a:prstGeom prst="rect">
             <a:avLst/>
@@ -1353,11 +1353,11 @@
           <a:bodyPr wrap="square" rtlCol="0" anchor="ctr"/>
           <a:lstStyle/>
           <a:p>
-            <a:pPr indent="0" marL="0">
+            <a:pPr algn="ctr" indent="0" marL="0">
               <a:buNone/>
             </a:pPr>
             <a:r>
-              <a:rPr lang="en-US" sz="1100" dirty="0">
+              <a:rPr lang="en-US" sz="1050" dirty="0">
                 <a:solidFill>
                   <a:srgbClr val="E2E8F0"/>
                 </a:solidFill>
@@ -1367,7 +1367,7 @@
               </a:rPr>
               <a:t>Salud mental y emocional pastoral.</a:t>
             </a:r>
-            <a:endParaRPr lang="en-US" sz="1100" dirty="0"/>
+            <a:endParaRPr lang="en-US" sz="1050" dirty="0"/>
           </a:p>
         </p:txBody>
       </p:sp>
@@ -1379,12 +1379,12 @@
         </p:nvSpPr>
         <p:spPr>
           <a:xfrm>
-            <a:off x="3337560" y="4572000"/>
-            <a:ext cx="2606040" cy="1645920"/>
+            <a:off x="3319272" y="4480560"/>
+            <a:ext cx="2633472" cy="1920240"/>
           </a:xfrm>
           <a:prstGeom prst="roundRect">
             <a:avLst>
-              <a:gd name="adj" fmla="val 5556"/>
+              <a:gd name="adj" fmla="val 4762"/>
             </a:avLst>
           </a:prstGeom>
           <a:solidFill>
@@ -1406,8 +1406,8 @@
         </p:nvSpPr>
         <p:spPr>
           <a:xfrm>
-            <a:off x="3474720" y="4800600"/>
-            <a:ext cx="2331720" cy="320040"/>
+            <a:off x="3429000" y="4663440"/>
+            <a:ext cx="2414016" cy="320040"/>
           </a:xfrm>
           <a:prstGeom prst="rect">
             <a:avLst/>
@@ -1419,11 +1419,11 @@
           <a:bodyPr wrap="square" rtlCol="0" anchor="ctr"/>
           <a:lstStyle/>
           <a:p>
-            <a:pPr indent="0" marL="0">
+            <a:pPr algn="ctr" indent="0" marL="0">
               <a:buNone/>
             </a:pPr>
             <a:r>
-              <a:rPr lang="en-US" sz="1400" b="1" dirty="0">
+              <a:rPr lang="en-US" sz="1300" b="1" dirty="0">
                 <a:solidFill>
                   <a:srgbClr val="FF8A50"/>
                 </a:solidFill>
@@ -1433,7 +1433,7 @@
               </a:rPr>
               <a:t>RESTAURAR</a:t>
             </a:r>
-            <a:endParaRPr lang="en-US" sz="1400" dirty="0"/>
+            <a:endParaRPr lang="en-US" sz="1300" dirty="0"/>
           </a:p>
         </p:txBody>
       </p:sp>
@@ -1445,8 +1445,8 @@
         </p:nvSpPr>
         <p:spPr>
           <a:xfrm>
-            <a:off x="3474720" y="5166360"/>
-            <a:ext cx="2331720" cy="822960"/>
+            <a:off x="3429000" y="5029200"/>
+            <a:ext cx="2414016" cy="1188720"/>
           </a:xfrm>
           <a:prstGeom prst="rect">
             <a:avLst/>
@@ -1458,11 +1458,11 @@
           <a:bodyPr wrap="square" rtlCol="0" anchor="ctr"/>
           <a:lstStyle/>
           <a:p>
-            <a:pPr indent="0" marL="0">
+            <a:pPr algn="ctr" indent="0" marL="0">
               <a:buNone/>
             </a:pPr>
             <a:r>
-              <a:rPr lang="en-US" sz="1100" dirty="0">
+              <a:rPr lang="en-US" sz="1050" dirty="0">
                 <a:solidFill>
                   <a:srgbClr val="E2E8F0"/>
                 </a:solidFill>
@@ -1472,7 +1472,7 @@
               </a:rPr>
               <a:t>Retiros y renovación espiritual.</a:t>
             </a:r>
-            <a:endParaRPr lang="en-US" sz="1100" dirty="0"/>
+            <a:endParaRPr lang="en-US" sz="1050" dirty="0"/>
           </a:p>
         </p:txBody>
       </p:sp>
@@ -1484,12 +1484,12 @@
         </p:nvSpPr>
         <p:spPr>
           <a:xfrm>
-            <a:off x="6126480" y="4572000"/>
-            <a:ext cx="2606040" cy="1645920"/>
+            <a:off x="6181344" y="4480560"/>
+            <a:ext cx="2633472" cy="1920240"/>
           </a:xfrm>
           <a:prstGeom prst="roundRect">
             <a:avLst>
-              <a:gd name="adj" fmla="val 5556"/>
+              <a:gd name="adj" fmla="val 4762"/>
             </a:avLst>
           </a:prstGeom>
           <a:solidFill>
@@ -1511,8 +1511,8 @@
         </p:nvSpPr>
         <p:spPr>
           <a:xfrm>
-            <a:off x="6263640" y="4800600"/>
-            <a:ext cx="2331720" cy="320040"/>
+            <a:off x="6291072" y="4663440"/>
+            <a:ext cx="2414016" cy="320040"/>
           </a:xfrm>
           <a:prstGeom prst="rect">
             <a:avLst/>
@@ -1524,11 +1524,11 @@
           <a:bodyPr wrap="square" rtlCol="0" anchor="ctr"/>
           <a:lstStyle/>
           <a:p>
-            <a:pPr indent="0" marL="0">
+            <a:pPr algn="ctr" indent="0" marL="0">
               <a:buNone/>
             </a:pPr>
             <a:r>
-              <a:rPr lang="en-US" sz="1400" b="1" dirty="0">
+              <a:rPr lang="en-US" sz="1300" b="1" dirty="0">
                 <a:solidFill>
                   <a:srgbClr val="FF8A50"/>
                 </a:solidFill>
@@ -1538,7 +1538,7 @@
               </a:rPr>
               <a:t>EQUIPAR</a:t>
             </a:r>
-            <a:endParaRPr lang="en-US" sz="1400" dirty="0"/>
+            <a:endParaRPr lang="en-US" sz="1300" dirty="0"/>
           </a:p>
         </p:txBody>
       </p:sp>
@@ -1550,8 +1550,8 @@
         </p:nvSpPr>
         <p:spPr>
           <a:xfrm>
-            <a:off x="6263640" y="5166360"/>
-            <a:ext cx="2331720" cy="822960"/>
+            <a:off x="6291072" y="5029200"/>
+            <a:ext cx="2414016" cy="1188720"/>
           </a:xfrm>
           <a:prstGeom prst="rect">
             <a:avLst/>
@@ -1563,11 +1563,11 @@
           <a:bodyPr wrap="square" rtlCol="0" anchor="ctr"/>
           <a:lstStyle/>
           <a:p>
-            <a:pPr indent="0" marL="0">
+            <a:pPr algn="ctr" indent="0" marL="0">
               <a:buNone/>
             </a:pPr>
             <a:r>
-              <a:rPr lang="en-US" sz="1100" dirty="0">
+              <a:rPr lang="en-US" sz="1050" dirty="0">
                 <a:solidFill>
                   <a:srgbClr val="E2E8F0"/>
                 </a:solidFill>
@@ -1577,7 +1577,7 @@
               </a:rPr>
               <a:t>Capacitación y mentoría práctica.</a:t>
             </a:r>
-            <a:endParaRPr lang="en-US" sz="1100" dirty="0"/>
+            <a:endParaRPr lang="en-US" sz="1050" dirty="0"/>
           </a:p>
         </p:txBody>
       </p:sp>
@@ -1589,12 +1589,12 @@
         </p:nvSpPr>
         <p:spPr>
           <a:xfrm>
-            <a:off x="8915400" y="4572000"/>
-            <a:ext cx="2606040" cy="1645920"/>
+            <a:off x="9043416" y="4480560"/>
+            <a:ext cx="2633472" cy="1920240"/>
           </a:xfrm>
           <a:prstGeom prst="roundRect">
             <a:avLst>
-              <a:gd name="adj" fmla="val 5556"/>
+              <a:gd name="adj" fmla="val 4762"/>
             </a:avLst>
           </a:prstGeom>
           <a:solidFill>
@@ -1616,8 +1616,8 @@
         </p:nvSpPr>
         <p:spPr>
           <a:xfrm>
-            <a:off x="9052560" y="4800600"/>
-            <a:ext cx="2331720" cy="320040"/>
+            <a:off x="9153144" y="4663440"/>
+            <a:ext cx="2414016" cy="320040"/>
           </a:xfrm>
           <a:prstGeom prst="rect">
             <a:avLst/>
@@ -1629,11 +1629,11 @@
           <a:bodyPr wrap="square" rtlCol="0" anchor="ctr"/>
           <a:lstStyle/>
           <a:p>
-            <a:pPr indent="0" marL="0">
+            <a:pPr algn="ctr" indent="0" marL="0">
               <a:buNone/>
             </a:pPr>
             <a:r>
-              <a:rPr lang="en-US" sz="1400" b="1" dirty="0">
+              <a:rPr lang="en-US" sz="1300" b="1" dirty="0">
                 <a:solidFill>
                   <a:srgbClr val="FF8A50"/>
                 </a:solidFill>
@@ -1643,7 +1643,7 @@
               </a:rPr>
               <a:t>CONECTAR</a:t>
             </a:r>
-            <a:endParaRPr lang="en-US" sz="1400" dirty="0"/>
+            <a:endParaRPr lang="en-US" sz="1300" dirty="0"/>
           </a:p>
         </p:txBody>
       </p:sp>
@@ -1655,8 +1655,8 @@
         </p:nvSpPr>
         <p:spPr>
           <a:xfrm>
-            <a:off x="9052560" y="5166360"/>
-            <a:ext cx="2331720" cy="822960"/>
+            <a:off x="9153144" y="5029200"/>
+            <a:ext cx="2414016" cy="1188720"/>
           </a:xfrm>
           <a:prstGeom prst="rect">
             <a:avLst/>
@@ -1668,11 +1668,11 @@
           <a:bodyPr wrap="square" rtlCol="0" anchor="ctr"/>
           <a:lstStyle/>
           <a:p>
-            <a:pPr indent="0" marL="0">
+            <a:pPr algn="ctr" indent="0" marL="0">
               <a:buNone/>
             </a:pPr>
             <a:r>
-              <a:rPr lang="en-US" sz="1100" dirty="0">
+              <a:rPr lang="en-US" sz="1050" dirty="0">
                 <a:solidFill>
                   <a:srgbClr val="E2E8F0"/>
                 </a:solidFill>
@@ -1682,7 +1682,7 @@
               </a:rPr>
               <a:t>Puentes de patrocinio y alianza.</a:t>
             </a:r>
-            <a:endParaRPr lang="en-US" sz="1100" dirty="0"/>
+            <a:endParaRPr lang="en-US" sz="1050" dirty="0"/>
           </a:p>
         </p:txBody>
       </p:sp>

</xml_diff>